<commit_message>
Add day 16 materials
</commit_message>
<xml_diff>
--- a/заняття_16/CSV_and_JSON_in_Python.pptx
+++ b/заняття_16/CSV_and_JSON_in_Python.pptx
@@ -3471,7 +3471,7 @@
         <p:spPr>
           <a:xfrm>
             <a:off x="548640" y="1600200"/>
-            <a:ext cx="4846320" cy="3200400"/>
+            <a:ext cx="4937760" cy="3200400"/>
           </a:xfrm>
           <a:prstGeom prst="roundRect">
             <a:avLst>
@@ -3626,8 +3626,8 @@
         </p:nvSpPr>
         <p:spPr>
           <a:xfrm>
-            <a:off x="804672" y="1965960"/>
-            <a:ext cx="4590288" cy="2697480"/>
+            <a:off x="685800" y="1931727"/>
+            <a:ext cx="4676699" cy="2697480"/>
           </a:xfrm>
           <a:prstGeom prst="rect">
             <a:avLst/>
@@ -3772,7 +3772,22 @@
                 <a:ea typeface="Consolas" pitchFamily="34" charset="-122"/>
                 <a:cs typeface="Consolas" pitchFamily="34" charset="-120"/>
               </a:rPr>
-              <a:t>with open('out.csv', 'w', newline='',</a:t>
+              <a:t>with open('out.csv', 'w', newline=’’,</a:t>
+            </a:r>
+            <a:r>
+              <a:rPr lang="uk-UA" sz="1100" dirty="0"/>
+              <a:t> </a:t>
+            </a:r>
+            <a:r>
+              <a:rPr lang="en-US" sz="1100" dirty="0">
+                <a:solidFill>
+                  <a:srgbClr val="CADCFC"/>
+                </a:solidFill>
+                <a:latin typeface="Consolas" pitchFamily="34" charset="0"/>
+                <a:ea typeface="Consolas" pitchFamily="34" charset="-122"/>
+                <a:cs typeface="Consolas" pitchFamily="34" charset="-120"/>
+              </a:rPr>
+              <a:t>encoding='utf-8') as f:</a:t>
             </a:r>
             <a:endParaRPr lang="en-US" sz="1100" dirty="0"/>
           </a:p>
@@ -3792,47 +3807,7 @@
                 <a:ea typeface="Consolas" pitchFamily="34" charset="-122"/>
                 <a:cs typeface="Consolas" pitchFamily="34" charset="-120"/>
               </a:rPr>
-              <a:t>          encoding='utf-8') as f:</a:t>
-            </a:r>
-            <a:endParaRPr lang="en-US" sz="1100" dirty="0"/>
-          </a:p>
-          <a:p>
-            <a:pPr marL="0" indent="0">
-              <a:lnSpc>
-                <a:spcPct val="125000"/>
-              </a:lnSpc>
-              <a:buNone/>
-            </a:pPr>
-            <a:r>
-              <a:rPr lang="en-US" sz="1100" dirty="0">
-                <a:solidFill>
-                  <a:srgbClr val="CADCFC"/>
-                </a:solidFill>
-                <a:latin typeface="Consolas" pitchFamily="34" charset="0"/>
-                <a:ea typeface="Consolas" pitchFamily="34" charset="-122"/>
-                <a:cs typeface="Consolas" pitchFamily="34" charset="-120"/>
-              </a:rPr>
-              <a:t>    writer = csv.DictWriter(</a:t>
-            </a:r>
-            <a:endParaRPr lang="en-US" sz="1100" dirty="0"/>
-          </a:p>
-          <a:p>
-            <a:pPr marL="0" indent="0">
-              <a:lnSpc>
-                <a:spcPct val="125000"/>
-              </a:lnSpc>
-              <a:buNone/>
-            </a:pPr>
-            <a:r>
-              <a:rPr lang="en-US" sz="1100" dirty="0">
-                <a:solidFill>
-                  <a:srgbClr val="CADCFC"/>
-                </a:solidFill>
-                <a:latin typeface="Consolas" pitchFamily="34" charset="0"/>
-                <a:ea typeface="Consolas" pitchFamily="34" charset="-122"/>
-                <a:cs typeface="Consolas" pitchFamily="34" charset="-120"/>
-              </a:rPr>
-              <a:t>        f, fieldnames=['name', 'grade'])</a:t>
+              <a:t>    writer = csv.DictWriter(f, fieldnames=['name', 'grade'])</a:t>
             </a:r>
             <a:endParaRPr lang="en-US" sz="1100" dirty="0"/>
           </a:p>
@@ -4024,7 +3999,23 @@
                   <a:srgbClr val="7A4E12"/>
                 </a:solidFill>
               </a:rPr>
-              <a:t>Без цього параметра Windows додає зайві порожні рядки між записами.</a:t>
+              <a:t>Без цього параметра Windows </a:t>
+            </a:r>
+            <a:r>
+              <a:rPr lang="uk-UA" sz="1050" dirty="0">
+                <a:solidFill>
+                  <a:srgbClr val="7A4E12"/>
+                </a:solidFill>
+              </a:rPr>
+              <a:t>може додавати</a:t>
+            </a:r>
+            <a:r>
+              <a:rPr lang="en-US" sz="1050" dirty="0">
+                <a:solidFill>
+                  <a:srgbClr val="7A4E12"/>
+                </a:solidFill>
+              </a:rPr>
+              <a:t> зайві порожні рядки між записами.</a:t>
             </a:r>
             <a:endParaRPr lang="en-US" sz="1050" dirty="0"/>
           </a:p>
@@ -6971,7 +6962,7 @@
         <p:spPr>
           <a:xfrm>
             <a:off x="804672" y="1965960"/>
-            <a:ext cx="4151376" cy="2514600"/>
+            <a:ext cx="4325112" cy="2514600"/>
           </a:xfrm>
           <a:prstGeom prst="rect">
             <a:avLst/>
@@ -7133,15 +7124,10 @@
               </a:rPr>
               <a:t>    json.dump(students, f,</a:t>
             </a:r>
-            <a:endParaRPr lang="en-US" sz="1100" dirty="0"/>
-          </a:p>
-          <a:p>
-            <a:pPr marL="0" indent="0">
-              <a:lnSpc>
-                <a:spcPct val="125000"/>
-              </a:lnSpc>
-              <a:buNone/>
-            </a:pPr>
+            <a:r>
+              <a:rPr lang="uk-UA" sz="1100" dirty="0"/>
+              <a:t> </a:t>
+            </a:r>
             <a:r>
               <a:rPr lang="en-US" sz="1100" dirty="0">
                 <a:solidFill>
@@ -7151,7 +7137,7 @@
                 <a:ea typeface="Consolas" pitchFamily="34" charset="-122"/>
                 <a:cs typeface="Consolas" pitchFamily="34" charset="-120"/>
               </a:rPr>
-              <a:t>               ensure_ascii=False, indent=2)</a:t>
+              <a:t>ensure_ascii=False, indent=2)</a:t>
             </a:r>
             <a:endParaRPr lang="en-US" sz="1100" dirty="0"/>
           </a:p>

</xml_diff>